<commit_message>
feat: Implement RAG strategies for retrieval and processing, including BasicFusion, CvsParallel, and GraphRag strategies; update config and app_langgraph for strategy selection
</commit_message>
<xml_diff>
--- a/doc/20260227_Presentacion_AnexoB.pptx
+++ b/doc/20260227_Presentacion_AnexoB.pptx
@@ -133,11 +133,11 @@
             <p14:sldId id="258"/>
             <p14:sldId id="268"/>
             <p14:sldId id="262"/>
+            <p14:sldId id="269"/>
           </p14:sldIdLst>
         </p14:section>
         <p14:section name="Resultados y estado actual" id="{673AEFD9-50FE-4A82-A53B-85175633FD40}">
           <p14:sldIdLst>
-            <p14:sldId id="269"/>
             <p14:sldId id="270"/>
           </p14:sldIdLst>
         </p14:section>
@@ -150,20 +150,12 @@
 </p:presentation>
 </file>
 
-<file path=ppt/revisionInfo.xml><?xml version="1.0" encoding="utf-8"?>
-<p1510:revInfo xmlns:a="http://schemas.openxmlformats.org/drawingml/2006/main" xmlns:r="http://schemas.openxmlformats.org/officeDocument/2006/relationships" xmlns:p1510="http://schemas.microsoft.com/office/powerpoint/2015/10/main">
-  <p1510:revLst>
-    <p1510:client id="{B8B30D3D-AB1C-4DCE-888A-F70CA2E70373}" v="56" dt="2026-04-17T21:19:07.630"/>
-  </p1510:revLst>
-</p1510:revInfo>
-</file>
-
 <file path=ppt/changesInfos/changesInfo1.xml><?xml version="1.0" encoding="utf-8"?>
 <pc:chgInfo xmlns:a="http://schemas.openxmlformats.org/drawingml/2006/main" xmlns:r="http://schemas.openxmlformats.org/officeDocument/2006/relationships" xmlns:ac="http://schemas.microsoft.com/office/drawing/2013/main/command" xmlns:pc="http://schemas.microsoft.com/office/powerpoint/2013/main/command">
   <pc:docChgLst>
     <pc:chgData name="Sofia Negueruela Avellaneda" userId="1355ce59-2ee3-4584-b6f2-c7e4b99958aa" providerId="ADAL" clId="{75AA7C8B-0E1E-45F8-BB8D-1CDD06E81B9F}"/>
     <pc:docChg chg="undo redo custSel addSld delSld modSld sldOrd addSection modSection">
-      <pc:chgData name="Sofia Negueruela Avellaneda" userId="1355ce59-2ee3-4584-b6f2-c7e4b99958aa" providerId="ADAL" clId="{75AA7C8B-0E1E-45F8-BB8D-1CDD06E81B9F}" dt="2026-04-17T21:19:46.971" v="2590" actId="20577"/>
+      <pc:chgData name="Sofia Negueruela Avellaneda" userId="1355ce59-2ee3-4584-b6f2-c7e4b99958aa" providerId="ADAL" clId="{75AA7C8B-0E1E-45F8-BB8D-1CDD06E81B9F}" dt="2026-04-30T16:06:10.613" v="2749" actId="20577"/>
       <pc:docMkLst>
         <pc:docMk/>
       </pc:docMkLst>
@@ -182,8 +174,8 @@
           </ac:spMkLst>
         </pc:spChg>
       </pc:sldChg>
-      <pc:sldChg chg="addSp delSp modSp ord">
-        <pc:chgData name="Sofia Negueruela Avellaneda" userId="1355ce59-2ee3-4584-b6f2-c7e4b99958aa" providerId="ADAL" clId="{75AA7C8B-0E1E-45F8-BB8D-1CDD06E81B9F}" dt="2026-04-17T21:18:42.076" v="2468"/>
+      <pc:sldChg chg="addSp delSp modSp mod ord modShow">
+        <pc:chgData name="Sofia Negueruela Avellaneda" userId="1355ce59-2ee3-4584-b6f2-c7e4b99958aa" providerId="ADAL" clId="{75AA7C8B-0E1E-45F8-BB8D-1CDD06E81B9F}" dt="2026-04-30T15:33:23.780" v="2593" actId="729"/>
         <pc:sldMkLst>
           <pc:docMk/>
           <pc:sldMk cId="1987742604" sldId="257"/>
@@ -204,22 +196,6 @@
             <ac:grpSpMk id="4" creationId="{219076BD-3A9F-ED8E-0424-86E085840F64}"/>
           </ac:grpSpMkLst>
         </pc:grpChg>
-        <pc:picChg chg="del">
-          <ac:chgData name="Sofia Negueruela Avellaneda" userId="1355ce59-2ee3-4584-b6f2-c7e4b99958aa" providerId="ADAL" clId="{75AA7C8B-0E1E-45F8-BB8D-1CDD06E81B9F}" dt="2026-04-17T21:18:41.526" v="2467" actId="478"/>
-          <ac:picMkLst>
-            <pc:docMk/>
-            <pc:sldMk cId="1987742604" sldId="257"/>
-            <ac:picMk id="1028" creationId="{A8F3D146-3702-98A4-CD6D-C9EB21828969}"/>
-          </ac:picMkLst>
-        </pc:picChg>
-        <pc:picChg chg="del">
-          <ac:chgData name="Sofia Negueruela Avellaneda" userId="1355ce59-2ee3-4584-b6f2-c7e4b99958aa" providerId="ADAL" clId="{75AA7C8B-0E1E-45F8-BB8D-1CDD06E81B9F}" dt="2026-04-17T21:18:41.526" v="2467" actId="478"/>
-          <ac:picMkLst>
-            <pc:docMk/>
-            <pc:sldMk cId="1987742604" sldId="257"/>
-            <ac:picMk id="1034" creationId="{ECAEE3CF-7C86-519E-D00A-16EEFC2B6614}"/>
-          </ac:picMkLst>
-        </pc:picChg>
         <pc:picChg chg="mod">
           <ac:chgData name="Sofia Negueruela Avellaneda" userId="1355ce59-2ee3-4584-b6f2-c7e4b99958aa" providerId="ADAL" clId="{75AA7C8B-0E1E-45F8-BB8D-1CDD06E81B9F}" dt="2026-04-17T21:18:42.076" v="2468"/>
           <ac:picMkLst>
@@ -251,22 +227,6 @@
             <ac:spMk id="7" creationId="{1DDCEBD5-515E-C525-00A4-39F656184B2C}"/>
           </ac:spMkLst>
         </pc:spChg>
-        <pc:grpChg chg="del">
-          <ac:chgData name="Sofia Negueruela Avellaneda" userId="1355ce59-2ee3-4584-b6f2-c7e4b99958aa" providerId="ADAL" clId="{75AA7C8B-0E1E-45F8-BB8D-1CDD06E81B9F}" dt="2026-04-17T21:18:32.831" v="2466" actId="21"/>
-          <ac:grpSpMkLst>
-            <pc:docMk/>
-            <pc:sldMk cId="1030600834" sldId="258"/>
-            <ac:grpSpMk id="4" creationId="{219076BD-3A9F-ED8E-0424-86E085840F64}"/>
-          </ac:grpSpMkLst>
-        </pc:grpChg>
-        <pc:graphicFrameChg chg="add del mod">
-          <ac:chgData name="Sofia Negueruela Avellaneda" userId="1355ce59-2ee3-4584-b6f2-c7e4b99958aa" providerId="ADAL" clId="{75AA7C8B-0E1E-45F8-BB8D-1CDD06E81B9F}" dt="2026-04-17T21:19:28.474" v="2531" actId="478"/>
-          <ac:graphicFrameMkLst>
-            <pc:docMk/>
-            <pc:sldMk cId="1030600834" sldId="258"/>
-            <ac:graphicFrameMk id="5" creationId="{17073054-FD1A-06E0-5256-528055FCDDF9}"/>
-          </ac:graphicFrameMkLst>
-        </pc:graphicFrameChg>
       </pc:sldChg>
       <pc:sldChg chg="ord">
         <pc:chgData name="Sofia Negueruela Avellaneda" userId="1355ce59-2ee3-4584-b6f2-c7e4b99958aa" providerId="ADAL" clId="{75AA7C8B-0E1E-45F8-BB8D-1CDD06E81B9F}" dt="2026-04-17T16:30:19.637" v="2369"/>
@@ -275,32 +235,18 @@
           <pc:sldMk cId="425261687" sldId="259"/>
         </pc:sldMkLst>
       </pc:sldChg>
-      <pc:sldChg chg="del">
-        <pc:chgData name="Sofia Negueruela Avellaneda" userId="1355ce59-2ee3-4584-b6f2-c7e4b99958aa" providerId="ADAL" clId="{75AA7C8B-0E1E-45F8-BB8D-1CDD06E81B9F}" dt="2026-04-17T16:30:06.464" v="2363" actId="47"/>
-        <pc:sldMkLst>
-          <pc:docMk/>
-          <pc:sldMk cId="3677430290" sldId="260"/>
-        </pc:sldMkLst>
-      </pc:sldChg>
-      <pc:sldChg chg="ord">
-        <pc:chgData name="Sofia Negueruela Avellaneda" userId="1355ce59-2ee3-4584-b6f2-c7e4b99958aa" providerId="ADAL" clId="{75AA7C8B-0E1E-45F8-BB8D-1CDD06E81B9F}" dt="2026-04-17T16:30:13.180" v="2367"/>
+      <pc:sldChg chg="mod ord modShow">
+        <pc:chgData name="Sofia Negueruela Avellaneda" userId="1355ce59-2ee3-4584-b6f2-c7e4b99958aa" providerId="ADAL" clId="{75AA7C8B-0E1E-45F8-BB8D-1CDD06E81B9F}" dt="2026-04-30T15:29:53.448" v="2591" actId="729"/>
         <pc:sldMkLst>
           <pc:docMk/>
           <pc:sldMk cId="2168037090" sldId="261"/>
         </pc:sldMkLst>
       </pc:sldChg>
-      <pc:sldChg chg="ord">
-        <pc:chgData name="Sofia Negueruela Avellaneda" userId="1355ce59-2ee3-4584-b6f2-c7e4b99958aa" providerId="ADAL" clId="{75AA7C8B-0E1E-45F8-BB8D-1CDD06E81B9F}" dt="2026-04-17T16:30:32.732" v="2373"/>
+      <pc:sldChg chg="mod ord modShow">
+        <pc:chgData name="Sofia Negueruela Avellaneda" userId="1355ce59-2ee3-4584-b6f2-c7e4b99958aa" providerId="ADAL" clId="{75AA7C8B-0E1E-45F8-BB8D-1CDD06E81B9F}" dt="2026-04-30T16:05:32.085" v="2653" actId="729"/>
         <pc:sldMkLst>
           <pc:docMk/>
           <pc:sldMk cId="2728812356" sldId="262"/>
-        </pc:sldMkLst>
-      </pc:sldChg>
-      <pc:sldChg chg="del">
-        <pc:chgData name="Sofia Negueruela Avellaneda" userId="1355ce59-2ee3-4584-b6f2-c7e4b99958aa" providerId="ADAL" clId="{75AA7C8B-0E1E-45F8-BB8D-1CDD06E81B9F}" dt="2026-04-17T16:30:58.922" v="2377" actId="47"/>
-        <pc:sldMkLst>
-          <pc:docMk/>
-          <pc:sldMk cId="1040330078" sldId="266"/>
         </pc:sldMkLst>
       </pc:sldChg>
       <pc:sldChg chg="modSp new mod">
@@ -341,14 +287,14 @@
           </ac:spMkLst>
         </pc:spChg>
       </pc:sldChg>
-      <pc:sldChg chg="modSp add mod">
-        <pc:chgData name="Sofia Negueruela Avellaneda" userId="1355ce59-2ee3-4584-b6f2-c7e4b99958aa" providerId="ADAL" clId="{75AA7C8B-0E1E-45F8-BB8D-1CDD06E81B9F}" dt="2026-04-17T16:32:34.309" v="2465" actId="20577"/>
+      <pc:sldChg chg="modSp add mod ord">
+        <pc:chgData name="Sofia Negueruela Avellaneda" userId="1355ce59-2ee3-4584-b6f2-c7e4b99958aa" providerId="ADAL" clId="{75AA7C8B-0E1E-45F8-BB8D-1CDD06E81B9F}" dt="2026-04-30T16:05:25.660" v="2652"/>
         <pc:sldMkLst>
           <pc:docMk/>
           <pc:sldMk cId="83607501" sldId="269"/>
         </pc:sldMkLst>
         <pc:spChg chg="mod">
-          <ac:chgData name="Sofia Negueruela Avellaneda" userId="1355ce59-2ee3-4584-b6f2-c7e4b99958aa" providerId="ADAL" clId="{75AA7C8B-0E1E-45F8-BB8D-1CDD06E81B9F}" dt="2026-04-17T16:31:09.761" v="2406" actId="20577"/>
+          <ac:chgData name="Sofia Negueruela Avellaneda" userId="1355ce59-2ee3-4584-b6f2-c7e4b99958aa" providerId="ADAL" clId="{75AA7C8B-0E1E-45F8-BB8D-1CDD06E81B9F}" dt="2026-04-30T16:05:22.104" v="2650" actId="20577"/>
           <ac:spMkLst>
             <pc:docMk/>
             <pc:sldMk cId="83607501" sldId="269"/>
@@ -365,17 +311,25 @@
         </pc:spChg>
       </pc:sldChg>
       <pc:sldChg chg="modSp add mod">
-        <pc:chgData name="Sofia Negueruela Avellaneda" userId="1355ce59-2ee3-4584-b6f2-c7e4b99958aa" providerId="ADAL" clId="{75AA7C8B-0E1E-45F8-BB8D-1CDD06E81B9F}" dt="2026-04-17T16:31:05.549" v="2396" actId="20577"/>
+        <pc:chgData name="Sofia Negueruela Avellaneda" userId="1355ce59-2ee3-4584-b6f2-c7e4b99958aa" providerId="ADAL" clId="{75AA7C8B-0E1E-45F8-BB8D-1CDD06E81B9F}" dt="2026-04-30T16:06:10.613" v="2749" actId="20577"/>
         <pc:sldMkLst>
           <pc:docMk/>
           <pc:sldMk cId="540189340" sldId="270"/>
         </pc:sldMkLst>
         <pc:spChg chg="mod">
-          <ac:chgData name="Sofia Negueruela Avellaneda" userId="1355ce59-2ee3-4584-b6f2-c7e4b99958aa" providerId="ADAL" clId="{75AA7C8B-0E1E-45F8-BB8D-1CDD06E81B9F}" dt="2026-04-17T16:31:05.549" v="2396" actId="20577"/>
+          <ac:chgData name="Sofia Negueruela Avellaneda" userId="1355ce59-2ee3-4584-b6f2-c7e4b99958aa" providerId="ADAL" clId="{75AA7C8B-0E1E-45F8-BB8D-1CDD06E81B9F}" dt="2026-04-30T16:05:48.664" v="2670" actId="20577"/>
           <ac:spMkLst>
             <pc:docMk/>
             <pc:sldMk cId="540189340" sldId="270"/>
             <ac:spMk id="2" creationId="{E98E98ED-E692-EEC6-40A0-9AD9A3FC76C0}"/>
+          </ac:spMkLst>
+        </pc:spChg>
+        <pc:spChg chg="mod">
+          <ac:chgData name="Sofia Negueruela Avellaneda" userId="1355ce59-2ee3-4584-b6f2-c7e4b99958aa" providerId="ADAL" clId="{75AA7C8B-0E1E-45F8-BB8D-1CDD06E81B9F}" dt="2026-04-30T16:06:10.613" v="2749" actId="20577"/>
+          <ac:spMkLst>
+            <pc:docMk/>
+            <pc:sldMk cId="540189340" sldId="270"/>
+            <ac:spMk id="3" creationId="{68B0B14C-B022-25C4-18CA-FDEDF12D37C6}"/>
           </ac:spMkLst>
         </pc:spChg>
       </pc:sldChg>
@@ -3310,13 +3264,13 @@
       <dgm:prSet presAssocID="{4352A6CA-5139-4EB1-B112-78D017F6D12E}" presName="iconRect" presStyleLbl="node1" presStyleIdx="0" presStyleCnt="3"/>
       <dgm:spPr>
         <a:blipFill>
-          <a:blip xmlns:r="http://schemas.openxmlformats.org/officeDocument/2006/relationships" r:embed="rId1">
+          <a:blip xmlns:r="http://schemas.openxmlformats.org/officeDocument/2006/relationships">
             <a:extLst>
               <a:ext uri="{28A0092B-C50C-407E-A947-70E740481C1C}">
                 <a14:useLocalDpi xmlns:a14="http://schemas.microsoft.com/office/drawing/2010/main" val="0"/>
               </a:ext>
               <a:ext uri="{96DAC541-7B7A-43D3-8B79-37D633B846F1}">
-                <asvg:svgBlip xmlns:asvg="http://schemas.microsoft.com/office/drawing/2016/SVG/main" r:embed="rId2"/>
+                <asvg:svgBlip xmlns:asvg="http://schemas.microsoft.com/office/drawing/2016/SVG/main" r:embed="rId1"/>
               </a:ext>
             </a:extLst>
           </a:blip>
@@ -3364,13 +3318,13 @@
       <dgm:prSet presAssocID="{38D9A974-7BA0-4DEF-9507-B2155A48B2E1}" presName="iconRect" presStyleLbl="node1" presStyleIdx="1" presStyleCnt="3"/>
       <dgm:spPr>
         <a:blipFill>
-          <a:blip xmlns:r="http://schemas.openxmlformats.org/officeDocument/2006/relationships" r:embed="rId3">
+          <a:blip xmlns:r="http://schemas.openxmlformats.org/officeDocument/2006/relationships">
             <a:extLst>
               <a:ext uri="{28A0092B-C50C-407E-A947-70E740481C1C}">
                 <a14:useLocalDpi xmlns:a14="http://schemas.microsoft.com/office/drawing/2010/main" val="0"/>
               </a:ext>
               <a:ext uri="{96DAC541-7B7A-43D3-8B79-37D633B846F1}">
-                <asvg:svgBlip xmlns:asvg="http://schemas.microsoft.com/office/drawing/2016/SVG/main" r:embed="rId4"/>
+                <asvg:svgBlip xmlns:asvg="http://schemas.microsoft.com/office/drawing/2016/SVG/main" r:embed="rId2"/>
               </a:ext>
             </a:extLst>
           </a:blip>
@@ -3418,13 +3372,13 @@
       <dgm:prSet presAssocID="{C2B509AA-4389-4F64-A5BE-26AC677292B9}" presName="iconRect" presStyleLbl="node1" presStyleIdx="2" presStyleCnt="3"/>
       <dgm:spPr>
         <a:blipFill>
-          <a:blip xmlns:r="http://schemas.openxmlformats.org/officeDocument/2006/relationships" r:embed="rId5">
+          <a:blip xmlns:r="http://schemas.openxmlformats.org/officeDocument/2006/relationships">
             <a:extLst>
               <a:ext uri="{28A0092B-C50C-407E-A947-70E740481C1C}">
                 <a14:useLocalDpi xmlns:a14="http://schemas.microsoft.com/office/drawing/2010/main" val="0"/>
               </a:ext>
               <a:ext uri="{96DAC541-7B7A-43D3-8B79-37D633B846F1}">
-                <asvg:svgBlip xmlns:asvg="http://schemas.microsoft.com/office/drawing/2016/SVG/main" r:embed="rId6"/>
+                <asvg:svgBlip xmlns:asvg="http://schemas.microsoft.com/office/drawing/2016/SVG/main" r:embed="rId3"/>
               </a:ext>
             </a:extLst>
           </a:blip>
@@ -3657,13 +3611,13 @@
       <dgm:prSet presAssocID="{2FEA03CC-5337-4D9A-83B7-D6AFB414A8CA}" presName="iconRect" presStyleLbl="node1" presStyleIdx="0" presStyleCnt="3"/>
       <dgm:spPr>
         <a:blipFill>
-          <a:blip xmlns:r="http://schemas.openxmlformats.org/officeDocument/2006/relationships" r:embed="rId1">
+          <a:blip xmlns:r="http://schemas.openxmlformats.org/officeDocument/2006/relationships">
             <a:extLst>
               <a:ext uri="{28A0092B-C50C-407E-A947-70E740481C1C}">
                 <a14:useLocalDpi xmlns:a14="http://schemas.microsoft.com/office/drawing/2010/main" val="0"/>
               </a:ext>
               <a:ext uri="{96DAC541-7B7A-43D3-8B79-37D633B846F1}">
-                <asvg:svgBlip xmlns:asvg="http://schemas.microsoft.com/office/drawing/2016/SVG/main" r:embed="rId2"/>
+                <asvg:svgBlip xmlns:asvg="http://schemas.microsoft.com/office/drawing/2016/SVG/main" r:embed="rId1"/>
               </a:ext>
             </a:extLst>
           </a:blip>
@@ -3711,13 +3665,13 @@
       <dgm:prSet presAssocID="{CC000874-6FD5-4D52-AFA7-D28320D8B787}" presName="iconRect" presStyleLbl="node1" presStyleIdx="1" presStyleCnt="3"/>
       <dgm:spPr>
         <a:blipFill>
-          <a:blip xmlns:r="http://schemas.openxmlformats.org/officeDocument/2006/relationships" r:embed="rId3">
+          <a:blip xmlns:r="http://schemas.openxmlformats.org/officeDocument/2006/relationships">
             <a:extLst>
               <a:ext uri="{28A0092B-C50C-407E-A947-70E740481C1C}">
                 <a14:useLocalDpi xmlns:a14="http://schemas.microsoft.com/office/drawing/2010/main" val="0"/>
               </a:ext>
               <a:ext uri="{96DAC541-7B7A-43D3-8B79-37D633B846F1}">
-                <asvg:svgBlip xmlns:asvg="http://schemas.microsoft.com/office/drawing/2016/SVG/main" r:embed="rId4"/>
+                <asvg:svgBlip xmlns:asvg="http://schemas.microsoft.com/office/drawing/2016/SVG/main" r:embed="rId2"/>
               </a:ext>
             </a:extLst>
           </a:blip>
@@ -3765,13 +3719,13 @@
       <dgm:prSet presAssocID="{9A01159B-6942-48E5-AEC6-7CD42C931007}" presName="iconRect" presStyleLbl="node1" presStyleIdx="2" presStyleCnt="3"/>
       <dgm:spPr>
         <a:blipFill>
-          <a:blip xmlns:r="http://schemas.openxmlformats.org/officeDocument/2006/relationships" r:embed="rId5">
+          <a:blip xmlns:r="http://schemas.openxmlformats.org/officeDocument/2006/relationships">
             <a:extLst>
               <a:ext uri="{28A0092B-C50C-407E-A947-70E740481C1C}">
                 <a14:useLocalDpi xmlns:a14="http://schemas.microsoft.com/office/drawing/2010/main" val="0"/>
               </a:ext>
               <a:ext uri="{96DAC541-7B7A-43D3-8B79-37D633B846F1}">
-                <asvg:svgBlip xmlns:asvg="http://schemas.microsoft.com/office/drawing/2016/SVG/main" r:embed="rId6"/>
+                <asvg:svgBlip xmlns:asvg="http://schemas.microsoft.com/office/drawing/2016/SVG/main" r:embed="rId3"/>
               </a:ext>
             </a:extLst>
           </a:blip>
@@ -4630,13 +4584,13 @@
           <a:avLst/>
         </a:prstGeom>
         <a:blipFill>
-          <a:blip xmlns:r="http://schemas.openxmlformats.org/officeDocument/2006/relationships" r:embed="rId1">
+          <a:blip xmlns:r="http://schemas.openxmlformats.org/officeDocument/2006/relationships">
             <a:extLst>
               <a:ext uri="{28A0092B-C50C-407E-A947-70E740481C1C}">
                 <a14:useLocalDpi xmlns:a14="http://schemas.microsoft.com/office/drawing/2010/main" val="0"/>
               </a:ext>
               <a:ext uri="{96DAC541-7B7A-43D3-8B79-37D633B846F1}">
-                <asvg:svgBlip xmlns:asvg="http://schemas.microsoft.com/office/drawing/2016/SVG/main" r:embed="rId2"/>
+                <asvg:svgBlip xmlns:asvg="http://schemas.microsoft.com/office/drawing/2016/SVG/main" r:embed="rId1"/>
               </a:ext>
             </a:extLst>
           </a:blip>
@@ -4783,13 +4737,13 @@
           <a:avLst/>
         </a:prstGeom>
         <a:blipFill>
-          <a:blip xmlns:r="http://schemas.openxmlformats.org/officeDocument/2006/relationships" r:embed="rId3">
+          <a:blip xmlns:r="http://schemas.openxmlformats.org/officeDocument/2006/relationships">
             <a:extLst>
               <a:ext uri="{28A0092B-C50C-407E-A947-70E740481C1C}">
                 <a14:useLocalDpi xmlns:a14="http://schemas.microsoft.com/office/drawing/2010/main" val="0"/>
               </a:ext>
               <a:ext uri="{96DAC541-7B7A-43D3-8B79-37D633B846F1}">
-                <asvg:svgBlip xmlns:asvg="http://schemas.microsoft.com/office/drawing/2016/SVG/main" r:embed="rId4"/>
+                <asvg:svgBlip xmlns:asvg="http://schemas.microsoft.com/office/drawing/2016/SVG/main" r:embed="rId2"/>
               </a:ext>
             </a:extLst>
           </a:blip>
@@ -4936,13 +4890,13 @@
           <a:avLst/>
         </a:prstGeom>
         <a:blipFill>
-          <a:blip xmlns:r="http://schemas.openxmlformats.org/officeDocument/2006/relationships" r:embed="rId5">
+          <a:blip xmlns:r="http://schemas.openxmlformats.org/officeDocument/2006/relationships">
             <a:extLst>
               <a:ext uri="{28A0092B-C50C-407E-A947-70E740481C1C}">
                 <a14:useLocalDpi xmlns:a14="http://schemas.microsoft.com/office/drawing/2010/main" val="0"/>
               </a:ext>
               <a:ext uri="{96DAC541-7B7A-43D3-8B79-37D633B846F1}">
-                <asvg:svgBlip xmlns:asvg="http://schemas.microsoft.com/office/drawing/2016/SVG/main" r:embed="rId6"/>
+                <asvg:svgBlip xmlns:asvg="http://schemas.microsoft.com/office/drawing/2016/SVG/main" r:embed="rId3"/>
               </a:ext>
             </a:extLst>
           </a:blip>
@@ -5101,13 +5055,13 @@
           <a:avLst/>
         </a:prstGeom>
         <a:blipFill>
-          <a:blip xmlns:r="http://schemas.openxmlformats.org/officeDocument/2006/relationships" r:embed="rId1">
+          <a:blip xmlns:r="http://schemas.openxmlformats.org/officeDocument/2006/relationships">
             <a:extLst>
               <a:ext uri="{28A0092B-C50C-407E-A947-70E740481C1C}">
                 <a14:useLocalDpi xmlns:a14="http://schemas.microsoft.com/office/drawing/2010/main" val="0"/>
               </a:ext>
               <a:ext uri="{96DAC541-7B7A-43D3-8B79-37D633B846F1}">
-                <asvg:svgBlip xmlns:asvg="http://schemas.microsoft.com/office/drawing/2016/SVG/main" r:embed="rId2"/>
+                <asvg:svgBlip xmlns:asvg="http://schemas.microsoft.com/office/drawing/2016/SVG/main" r:embed="rId1"/>
               </a:ext>
             </a:extLst>
           </a:blip>
@@ -5254,13 +5208,13 @@
           <a:avLst/>
         </a:prstGeom>
         <a:blipFill>
-          <a:blip xmlns:r="http://schemas.openxmlformats.org/officeDocument/2006/relationships" r:embed="rId3">
+          <a:blip xmlns:r="http://schemas.openxmlformats.org/officeDocument/2006/relationships">
             <a:extLst>
               <a:ext uri="{28A0092B-C50C-407E-A947-70E740481C1C}">
                 <a14:useLocalDpi xmlns:a14="http://schemas.microsoft.com/office/drawing/2010/main" val="0"/>
               </a:ext>
               <a:ext uri="{96DAC541-7B7A-43D3-8B79-37D633B846F1}">
-                <asvg:svgBlip xmlns:asvg="http://schemas.microsoft.com/office/drawing/2016/SVG/main" r:embed="rId4"/>
+                <asvg:svgBlip xmlns:asvg="http://schemas.microsoft.com/office/drawing/2016/SVG/main" r:embed="rId2"/>
               </a:ext>
             </a:extLst>
           </a:blip>
@@ -5407,13 +5361,13 @@
           <a:avLst/>
         </a:prstGeom>
         <a:blipFill>
-          <a:blip xmlns:r="http://schemas.openxmlformats.org/officeDocument/2006/relationships" r:embed="rId5">
+          <a:blip xmlns:r="http://schemas.openxmlformats.org/officeDocument/2006/relationships">
             <a:extLst>
               <a:ext uri="{28A0092B-C50C-407E-A947-70E740481C1C}">
                 <a14:useLocalDpi xmlns:a14="http://schemas.microsoft.com/office/drawing/2010/main" val="0"/>
               </a:ext>
               <a:ext uri="{96DAC541-7B7A-43D3-8B79-37D633B846F1}">
-                <asvg:svgBlip xmlns:asvg="http://schemas.microsoft.com/office/drawing/2016/SVG/main" r:embed="rId6"/>
+                <asvg:svgBlip xmlns:asvg="http://schemas.microsoft.com/office/drawing/2016/SVG/main" r:embed="rId3"/>
               </a:ext>
             </a:extLst>
           </a:blip>
@@ -10356,7 +10310,7 @@
           <a:p>
             <a:fld id="{11DDA3B7-DF4B-4512-9353-21E7A8669511}" type="datetimeFigureOut">
               <a:rPr lang="es-ES" smtClean="0"/>
-              <a:t>17/04/2026</a:t>
+              <a:t>30/04/2026</a:t>
             </a:fld>
             <a:endParaRPr lang="es-ES"/>
           </a:p>
@@ -11394,7 +11348,7 @@
           <a:p>
             <a:fld id="{FA838AF1-FF45-4AF1-AEA9-0AA3EBC94766}" type="datetimeFigureOut">
               <a:rPr lang="es-ES" smtClean="0"/>
-              <a:t>17/04/2026</a:t>
+              <a:t>30/04/2026</a:t>
             </a:fld>
             <a:endParaRPr lang="es-ES"/>
           </a:p>
@@ -11592,7 +11546,7 @@
           <a:p>
             <a:fld id="{FA838AF1-FF45-4AF1-AEA9-0AA3EBC94766}" type="datetimeFigureOut">
               <a:rPr lang="es-ES" smtClean="0"/>
-              <a:t>17/04/2026</a:t>
+              <a:t>30/04/2026</a:t>
             </a:fld>
             <a:endParaRPr lang="es-ES"/>
           </a:p>
@@ -11800,7 +11754,7 @@
           <a:p>
             <a:fld id="{FA838AF1-FF45-4AF1-AEA9-0AA3EBC94766}" type="datetimeFigureOut">
               <a:rPr lang="es-ES" smtClean="0"/>
-              <a:t>17/04/2026</a:t>
+              <a:t>30/04/2026</a:t>
             </a:fld>
             <a:endParaRPr lang="es-ES"/>
           </a:p>
@@ -11998,7 +11952,7 @@
           <a:p>
             <a:fld id="{FA838AF1-FF45-4AF1-AEA9-0AA3EBC94766}" type="datetimeFigureOut">
               <a:rPr lang="es-ES" smtClean="0"/>
-              <a:t>17/04/2026</a:t>
+              <a:t>30/04/2026</a:t>
             </a:fld>
             <a:endParaRPr lang="es-ES"/>
           </a:p>
@@ -12273,7 +12227,7 @@
           <a:p>
             <a:fld id="{FA838AF1-FF45-4AF1-AEA9-0AA3EBC94766}" type="datetimeFigureOut">
               <a:rPr lang="es-ES" smtClean="0"/>
-              <a:t>17/04/2026</a:t>
+              <a:t>30/04/2026</a:t>
             </a:fld>
             <a:endParaRPr lang="es-ES"/>
           </a:p>
@@ -12538,7 +12492,7 @@
           <a:p>
             <a:fld id="{FA838AF1-FF45-4AF1-AEA9-0AA3EBC94766}" type="datetimeFigureOut">
               <a:rPr lang="es-ES" smtClean="0"/>
-              <a:t>17/04/2026</a:t>
+              <a:t>30/04/2026</a:t>
             </a:fld>
             <a:endParaRPr lang="es-ES"/>
           </a:p>
@@ -12950,7 +12904,7 @@
           <a:p>
             <a:fld id="{FA838AF1-FF45-4AF1-AEA9-0AA3EBC94766}" type="datetimeFigureOut">
               <a:rPr lang="es-ES" smtClean="0"/>
-              <a:t>17/04/2026</a:t>
+              <a:t>30/04/2026</a:t>
             </a:fld>
             <a:endParaRPr lang="es-ES"/>
           </a:p>
@@ -13091,7 +13045,7 @@
           <a:p>
             <a:fld id="{FA838AF1-FF45-4AF1-AEA9-0AA3EBC94766}" type="datetimeFigureOut">
               <a:rPr lang="es-ES" smtClean="0"/>
-              <a:t>17/04/2026</a:t>
+              <a:t>30/04/2026</a:t>
             </a:fld>
             <a:endParaRPr lang="es-ES"/>
           </a:p>
@@ -13204,7 +13158,7 @@
           <a:p>
             <a:fld id="{FA838AF1-FF45-4AF1-AEA9-0AA3EBC94766}" type="datetimeFigureOut">
               <a:rPr lang="es-ES" smtClean="0"/>
-              <a:t>17/04/2026</a:t>
+              <a:t>30/04/2026</a:t>
             </a:fld>
             <a:endParaRPr lang="es-ES"/>
           </a:p>
@@ -13515,7 +13469,7 @@
           <a:p>
             <a:fld id="{FA838AF1-FF45-4AF1-AEA9-0AA3EBC94766}" type="datetimeFigureOut">
               <a:rPr lang="es-ES" smtClean="0"/>
-              <a:t>17/04/2026</a:t>
+              <a:t>30/04/2026</a:t>
             </a:fld>
             <a:endParaRPr lang="es-ES"/>
           </a:p>
@@ -13803,7 +13757,7 @@
           <a:p>
             <a:fld id="{FA838AF1-FF45-4AF1-AEA9-0AA3EBC94766}" type="datetimeFigureOut">
               <a:rPr lang="es-ES" smtClean="0"/>
-              <a:t>17/04/2026</a:t>
+              <a:t>30/04/2026</a:t>
             </a:fld>
             <a:endParaRPr lang="es-ES"/>
           </a:p>
@@ -14044,7 +13998,7 @@
           <a:p>
             <a:fld id="{FA838AF1-FF45-4AF1-AEA9-0AA3EBC94766}" type="datetimeFigureOut">
               <a:rPr lang="es-ES" smtClean="0"/>
-              <a:t>17/04/2026</a:t>
+              <a:t>30/04/2026</a:t>
             </a:fld>
             <a:endParaRPr lang="es-ES"/>
           </a:p>
@@ -15428,7 +15382,7 @@
           <a:p>
             <a:r>
               <a:rPr lang="es-ES" dirty="0"/>
-              <a:t>Estado actual</a:t>
+              <a:t>Resultados (estado actual)</a:t>
             </a:r>
           </a:p>
         </p:txBody>
@@ -15454,7 +15408,27 @@
           <a:bodyPr/>
           <a:lstStyle/>
           <a:p>
-            <a:endParaRPr lang="es-ES"/>
+            <a:r>
+              <a:rPr lang="es-ES" dirty="0" err="1"/>
+              <a:t>Check</a:t>
+            </a:r>
+            <a:r>
+              <a:rPr lang="es-ES" dirty="0"/>
+              <a:t> </a:t>
+            </a:r>
+            <a:r>
+              <a:rPr lang="es-ES" dirty="0" err="1"/>
+              <a:t>list</a:t>
+            </a:r>
+            <a:r>
+              <a:rPr lang="es-ES" dirty="0"/>
+              <a:t> de los objetivos (diapo inicial) y breve resumen de lo que he hecho, lo que falta y cómo va </a:t>
+            </a:r>
+            <a:r>
+              <a:rPr lang="es-ES"/>
+              <a:t>el proyecto</a:t>
+            </a:r>
+            <a:endParaRPr lang="es-ES" dirty="0"/>
           </a:p>
         </p:txBody>
       </p:sp>
@@ -15472,7 +15446,7 @@
 </file>
 
 <file path=ppt/slides/slide2.xml><?xml version="1.0" encoding="utf-8"?>
-<p:sld xmlns:a="http://schemas.openxmlformats.org/drawingml/2006/main" xmlns:r="http://schemas.openxmlformats.org/officeDocument/2006/relationships" xmlns:p="http://schemas.openxmlformats.org/presentationml/2006/main">
+<p:sld xmlns:a="http://schemas.openxmlformats.org/drawingml/2006/main" xmlns:r="http://schemas.openxmlformats.org/officeDocument/2006/relationships" xmlns:p="http://schemas.openxmlformats.org/presentationml/2006/main" show="0">
   <p:cSld>
     <p:bg>
       <p:bgPr>
@@ -17243,7 +17217,7 @@
 </file>
 
 <file path=ppt/slides/slide8.xml><?xml version="1.0" encoding="utf-8"?>
-<p:sld xmlns:a="http://schemas.openxmlformats.org/drawingml/2006/main" xmlns:r="http://schemas.openxmlformats.org/officeDocument/2006/relationships" xmlns:p="http://schemas.openxmlformats.org/presentationml/2006/main">
+<p:sld xmlns:a="http://schemas.openxmlformats.org/drawingml/2006/main" xmlns:r="http://schemas.openxmlformats.org/officeDocument/2006/relationships" xmlns:p="http://schemas.openxmlformats.org/presentationml/2006/main" show="0">
   <p:cSld>
     <p:bg>
       <p:bgPr>
@@ -17697,9 +17671,10 @@
           <a:lstStyle/>
           <a:p>
             <a:r>
-              <a:rPr lang="es-ES" dirty="0"/>
-              <a:t>Resultados</a:t>
+              <a:rPr lang="es-ES" dirty="0" err="1"/>
+              <a:t>Testing</a:t>
             </a:r>
+            <a:endParaRPr lang="es-ES" dirty="0"/>
           </a:p>
         </p:txBody>
       </p:sp>

</xml_diff>